<commit_message>
doc: italian version paper
</commit_message>
<xml_diff>
--- a/slides/The_Legend_Challenge.pptx
+++ b/slides/The_Legend_Challenge.pptx
@@ -27671,7 +27671,7 @@
         </p:nvSpPr>
         <p:spPr>
           <a:xfrm rot="-180000">
-            <a:off x="8359378" y="5436391"/>
+            <a:off x="8253072" y="5436391"/>
             <a:ext cx="1714500" cy="581025"/>
           </a:xfrm>
           <a:prstGeom prst="rect">
@@ -27703,7 +27703,7 @@
         </p:nvSpPr>
         <p:spPr>
           <a:xfrm rot="21346768">
-            <a:off x="8533316" y="5571870"/>
+            <a:off x="8434364" y="5609255"/>
             <a:ext cx="1406779" cy="310065"/>
           </a:xfrm>
           <a:prstGeom prst="rect">

</xml_diff>